<commit_message>
Remove course/institution line from final deck title slide
Co-Authored-By: Claude Sonnet 5.5 <noreply@anthropic.com>
</commit_message>
<xml_diff>
--- a/outputs/Uber_FindMyRide_Final_Presentation.pptx
+++ b/outputs/Uber_FindMyRide_Final_Presentation.pptx
@@ -4264,45 +4264,6 @@
                 <a:latin typeface="Calibri"/>
               </a:rPr>
               <a:t>When I have booked a ride from a busy or complex place, I want to meet my driver quickly and with certainty, so I can start my trip on time without stress.</a:t>
-            </a:r>
-          </a:p>
-        </p:txBody>
-      </p:sp>
-      <p:sp>
-        <p:nvSpPr>
-          <p:cNvPr id="6" name="TextBox 5"/>
-          <p:cNvSpPr txBox="1"/>
-          <p:nvPr/>
-        </p:nvSpPr>
-        <p:spPr>
-          <a:xfrm>
-            <a:off x="731520" y="5760720"/>
-            <a:ext cx="10698480" cy="548640"/>
-          </a:xfrm>
-          <a:prstGeom prst="rect">
-            <a:avLst/>
-          </a:prstGeom>
-          <a:noFill/>
-        </p:spPr>
-        <p:txBody>
-          <a:bodyPr wrap="square" anchor="t" lIns="45720" rIns="45720">
-            <a:spAutoFit/>
-          </a:bodyPr>
-          <a:lstStyle/>
-          <a:p>
-            <a:pPr algn="l">
-              <a:spcAft>
-                <a:spcPts val="600"/>
-              </a:spcAft>
-            </a:pPr>
-            <a:r>
-              <a:rPr sz="1600" b="0">
-                <a:solidFill>
-                  <a:srgbClr val="94A3B8"/>
-                </a:solidFill>
-                <a:latin typeface="Calibri"/>
-              </a:rPr>
-              <a:t>AI Product Management assignment, IIMA AGMP</a:t>
             </a:r>
           </a:p>
         </p:txBody>

</xml_diff>

<commit_message>
Remove speaker notes from final presentation
Co-Authored-By: Claude Sonnet 5.5 <noreply@anthropic.com>
</commit_message>
<xml_diff>
--- a/outputs/Uber_FindMyRide_Final_Presentation.pptx
+++ b/outputs/Uber_FindMyRide_Final_Presentation.pptx
@@ -508,11 +508,7 @@
         <p:txBody>
           <a:bodyPr/>
           <a:lstStyle/>
-          <a:p>
-            <a:r>
-              <a:t>I will show why riders and drivers struggle to find each other at pickup, and which problem to take into discovery first. I frame it with the job the rider is hiring Uber to do at that moment: meet my driver quickly and with certainty from a busy place. Evidence, priority and experiment all hang off that job.</a:t>
-            </a:r>
-          </a:p>
+          <a:p/>
         </p:txBody>
       </p:sp>
       <p:sp>
@@ -578,11 +574,7 @@
         <p:txBody>
           <a:bodyPr/>
           <a:lstStyle/>
-          <a:p>
-            <a:r>
-              <a:t>Two lenses: a survey with 27 responses, 24 valid Uber users, and 33 App Store reviews from India, collected 12 Sep 2026 to 14 Oct 2026, about five weeks, not six months. Both are small and self-selected, so they show what to test, not how common anything is. I use five light frameworks, each for a reason: jobs to be done to define the need, a journey map to locate the friction, a weighted matrix to make prioritisation explicit, build-measure-learn to keep the experiment small, and a metric tree to tie it to business outcomes.</a:t>
-            </a:r>
-          </a:p>
+          <a:p/>
         </p:txBody>
       </p:sp>
       <p:sp>
@@ -648,11 +640,7 @@
         <p:txBody>
           <a:bodyPr/>
           <a:lstStyle/>
-          <a:p>
-            <a:r>
-              <a:t>Here is the survey on the customer journey. Friction piles up early, at stage two, where riders interpret the pickup point: gate confusion 13 of 24, wrong pin 10. Then waiting 11, and calls for directions 11. I used a journey map because it shows where the breakdown starts, not just what is reported. The stage mapping is my judgement, and these are respondent counts, not rates. The implication: the earliest place to intervene is shared understanding of where to meet.</a:t>
-            </a:r>
-          </a:p>
+          <a:p/>
         </p:txBody>
       </p:sp>
       <p:sp>
@@ -718,11 +706,7 @@
         <p:txBody>
           <a:bodyPr/>
           <a:lstStyle/>
-          <a:p>
-            <a:r>
-              <a:t>Reviews map differently. Of 33, 22 mention cancellation, and the journey view shows them clustering at the outcome stage and during the approach. Waiting and communication appear again, about a quarter each. Fare disputes, 9 reviews, I keep separate, since they are not about finding the rider. Gate and pin appear in only 2 reviews each. Reviews describe how a trip ended, so I treat cancellation as a symptom to measure, not diagnose.</a:t>
-            </a:r>
-          </a:p>
+          <a:p/>
         </p:txBody>
       </p:sp>
       <p:sp>
@@ -788,11 +772,7 @@
         <p:txBody>
           <a:bodyPr/>
           <a:lstStyle/>
-          <a:p>
-            <a:r>
-              <a:t>Side by side, waiting and communication appear in both lenses, which gives some confidence they are real. The survey asks where and how pickups get hard, so it surfaces stage two: gates and pins. Reviews capture bad outcomes, so cancellation dominates. Fewer gate and pin mentions in reviews does not contradict the survey: different questions, people and weeks. What I cannot say is how common any of this is, or that gate or pin confusion causes cancellations. Nothing in the reviews links them. Use the survey to choose where to dig, and the reviews to choose what to track.</a:t>
-            </a:r>
-          </a:p>
+          <a:p/>
         </p:txBody>
       </p:sp>
       <p:sp>
@@ -858,11 +838,7 @@
         <p:txBody>
           <a:bodyPr/>
           <a:lstStyle/>
-          <a:p>
-            <a:r>
-              <a:t>To decide what to prioritise I used a weighted matrix, because it forces me to show my reasoning. Six criteria, weights on the slide, each hypothesis scored one to three. These are my judgements, not measurements. Meeting-point ambiguity scores highest, and stays first under three alternative weightings. Coordination friction is the related mechanism. Cancellation scores high on impact and frequency, but evidence linking it to coordination is weak and many causes sit outside scope, so it is an outcome to measure, not the first bet. On market size, this is an illustrative scenario: about 2.4 billion pickup events at the top, 3.5 million potentially improved, roughly five crore rupees of platform revenue, resting on unvalidated assumptions. Not a forecast, not profit.</a:t>
-            </a:r>
-          </a:p>
+          <a:p/>
         </p:txBody>
       </p:sp>
       <p:sp>
@@ -928,11 +904,7 @@
         <p:txBody>
           <a:bodyPr/>
           <a:lstStyle/>
-          <a:p>
-            <a:r>
-              <a:t>The experiment follows build, measure, learn, so we spend little before we learn. Build: a clickable prototype of structured meeting-point guidance against today's pin, not a committed feature. Measure: whether both sides agree on the same accessible spot, time to meet, clarification steps. Phase one is moderated testing with about eight to twelve riders and five to eight drivers; a field pilot follows only if it looks promising. The metric tree links meeting success to coordination time, calls and walking, and to cancellations, then to retained trips and rider time. The twenty percent cut in median coordination time is a proposed criterion, not a claim, and I am not claiming statistical power. Safety, accessibility, distraction and privacy are guardrails.</a:t>
-            </a:r>
-          </a:p>
+          <a:p/>
         </p:txBody>
       </p:sp>
       <p:sp>
@@ -998,11 +970,7 @@
         <p:txBody>
           <a:bodyPr/>
           <a:lstStyle/>
-          <a:p>
-            <a:r>
-              <a:t>This is the decision chain. The customer job: meet my driver quickly and with certainty. The friction we observed in both sources. The prioritised hypothesis, H1. One experiment. And an investment decision. We know confusion, waiting and communication problems appear in both sources. We hypothesise shared meeting-point information reduces effort. We will test it. Investment follows observed gains in pickup success and coordination time, with no safety or accessibility harm.</a:t>
-            </a:r>
-          </a:p>
+          <a:p/>
         </p:txBody>
       </p:sp>
       <p:sp>
@@ -1068,11 +1036,7 @@
         <p:txBody>
           <a:bodyPr/>
           <a:lstStyle/>
-          <a:p>
-            <a:r>
-              <a:t>These are the supporting research datasets, source records and analysis files. They are available for review.</a:t>
-            </a:r>
-          </a:p>
+          <a:p/>
         </p:txBody>
       </p:sp>
       <p:sp>

</xml_diff>